<commit_message>
Figures 1 and 2: flatter layouts printed at full column / text width
Figure 2 moves to an 11-inch canvas with shorter panel text, so the same point
sizes print about 38% larger at \textwidth; Figure 1 rows and stage boxes are
tightened to 240x325 pt so it prints at full \columnwidth at the old height.
Editable PowerPoint files regenerated.

Co-Authored-By: Claude Opus 5.5 <noreply@anthropic.com>
</commit_message>
<xml_diff>
--- a/docs/draft/Figures/worked_example_editable.pptx
+++ b/docs/draft/Figures/worked_example_editable.pptx
@@ -7,7 +7,7 @@
   <p:sldIdLst>
     <p:sldId id="256" r:id="rId7"/>
   </p:sldIdLst>
-  <p:sldSz cx="3048000" cy="4584700" type="screen4x3"/>
+  <p:sldSz cx="3048000" cy="4127500" type="screen4x3"/>
   <p:notesSz cx="6858000" cy="9144000"/>
   <p:defaultTextStyle>
     <a:defPPr>
@@ -3097,7 +3097,7 @@
         <p:spPr>
           <a:xfrm>
             <a:off x="63500" y="63500"/>
-            <a:ext cx="2921000" cy="381000"/>
+            <a:ext cx="2921000" cy="342900"/>
           </a:xfrm>
           <a:prstGeom prst="rect">
             <a:avLst/>
@@ -3288,8 +3288,8 @@
         </p:nvSpPr>
         <p:spPr>
           <a:xfrm>
-            <a:off x="63500" y="508000"/>
-            <a:ext cx="2921000" cy="2032000"/>
+            <a:off x="63500" y="457200"/>
+            <a:ext cx="2921000" cy="1905000"/>
           </a:xfrm>
           <a:prstGeom prst="rect">
             <a:avLst/>
@@ -3332,7 +3332,7 @@
         </p:nvSpPr>
         <p:spPr>
           <a:xfrm>
-            <a:off x="127000" y="519430"/>
+            <a:off x="127000" y="468630"/>
             <a:ext cx="1382996" cy="191770"/>
           </a:xfrm>
           <a:prstGeom prst="rect">
@@ -3376,7 +3376,7 @@
         </p:nvSpPr>
         <p:spPr>
           <a:xfrm>
-            <a:off x="184150" y="565444"/>
+            <a:off x="184150" y="514644"/>
             <a:ext cx="1498207" cy="170688"/>
           </a:xfrm>
           <a:prstGeom prst="rect">
@@ -3419,7 +3419,7 @@
         </p:blipFill>
         <p:spPr>
           <a:xfrm>
-            <a:off x="2705100" y="558800"/>
+            <a:off x="2705100" y="508000"/>
             <a:ext cx="190500" cy="190500"/>
           </a:xfrm>
           <a:prstGeom prst="rect">
@@ -3443,7 +3443,7 @@
         </p:blipFill>
         <p:spPr>
           <a:xfrm>
-            <a:off x="139700" y="800100"/>
+            <a:off x="139700" y="749300"/>
             <a:ext cx="139700" cy="139700"/>
           </a:xfrm>
           <a:prstGeom prst="rect">
@@ -3459,7 +3459,7 @@
         </p:nvSpPr>
         <p:spPr>
           <a:xfrm>
-            <a:off x="317500" y="784351"/>
+            <a:off x="317500" y="733551"/>
             <a:ext cx="549217" cy="135127"/>
           </a:xfrm>
           <a:prstGeom prst="rect">
@@ -3494,7 +3494,7 @@
         </p:nvSpPr>
         <p:spPr>
           <a:xfrm>
-            <a:off x="317500" y="891921"/>
+            <a:off x="317500" y="830961"/>
             <a:ext cx="573105" cy="129793"/>
           </a:xfrm>
           <a:prstGeom prst="rect">
@@ -3529,7 +3529,7 @@
         </p:nvSpPr>
         <p:spPr>
           <a:xfrm>
-            <a:off x="1079500" y="800100"/>
+            <a:off x="1079500" y="749300"/>
             <a:ext cx="457200" cy="177800"/>
           </a:xfrm>
           <a:prstGeom prst="roundRect">
@@ -3575,7 +3575,7 @@
         </p:nvSpPr>
         <p:spPr>
           <a:xfrm>
-            <a:off x="1120140" y="866140"/>
+            <a:off x="1120140" y="815340"/>
             <a:ext cx="45720" cy="45720"/>
           </a:xfrm>
           <a:prstGeom prst="ellipse">
@@ -3617,7 +3617,7 @@
         </p:nvSpPr>
         <p:spPr>
           <a:xfrm>
-            <a:off x="1189990" y="866140"/>
+            <a:off x="1189990" y="815340"/>
             <a:ext cx="45720" cy="45720"/>
           </a:xfrm>
           <a:prstGeom prst="ellipse">
@@ -3659,7 +3659,7 @@
         </p:nvCxnSpPr>
         <p:spPr>
           <a:xfrm>
-            <a:off x="1551940" y="889000"/>
+            <a:off x="1551940" y="838200"/>
             <a:ext cx="83820" cy="0"/>
           </a:xfrm>
           <a:prstGeom prst="line">
@@ -3696,7 +3696,7 @@
         </p:nvSpPr>
         <p:spPr>
           <a:xfrm>
-            <a:off x="1651000" y="800100"/>
+            <a:off x="1651000" y="749300"/>
             <a:ext cx="457200" cy="177800"/>
           </a:xfrm>
           <a:prstGeom prst="roundRect">
@@ -3742,7 +3742,7 @@
         </p:nvSpPr>
         <p:spPr>
           <a:xfrm>
-            <a:off x="1676400" y="825500"/>
+            <a:off x="1676400" y="774700"/>
             <a:ext cx="127000" cy="127000"/>
           </a:xfrm>
           <a:prstGeom prst="ellipse">
@@ -3786,7 +3786,7 @@
         </p:nvSpPr>
         <p:spPr>
           <a:xfrm>
-            <a:off x="1644902" y="841883"/>
+            <a:off x="1644902" y="791083"/>
             <a:ext cx="189995" cy="122682"/>
           </a:xfrm>
           <a:prstGeom prst="rect">
@@ -3821,7 +3821,7 @@
         </p:nvSpPr>
         <p:spPr>
           <a:xfrm>
-            <a:off x="1837689" y="866140"/>
+            <a:off x="1837689" y="815340"/>
             <a:ext cx="45720" cy="45720"/>
           </a:xfrm>
           <a:prstGeom prst="ellipse">
@@ -3863,7 +3863,7 @@
         </p:nvCxnSpPr>
         <p:spPr>
           <a:xfrm>
-            <a:off x="2123440" y="889000"/>
+            <a:off x="2123440" y="838200"/>
             <a:ext cx="83820" cy="0"/>
           </a:xfrm>
           <a:prstGeom prst="line">
@@ -3900,7 +3900,7 @@
         </p:nvSpPr>
         <p:spPr>
           <a:xfrm>
-            <a:off x="2222500" y="800100"/>
+            <a:off x="2222500" y="749300"/>
             <a:ext cx="457200" cy="177800"/>
           </a:xfrm>
           <a:prstGeom prst="roundRect">
@@ -3946,7 +3946,7 @@
         </p:nvSpPr>
         <p:spPr>
           <a:xfrm>
-            <a:off x="2247900" y="825500"/>
+            <a:off x="2247900" y="774700"/>
             <a:ext cx="127000" cy="127000"/>
           </a:xfrm>
           <a:prstGeom prst="ellipse">
@@ -3990,7 +3990,7 @@
         </p:nvSpPr>
         <p:spPr>
           <a:xfrm>
-            <a:off x="2216453" y="841883"/>
+            <a:off x="2216453" y="791083"/>
             <a:ext cx="189892" cy="122682"/>
           </a:xfrm>
           <a:prstGeom prst="rect">
@@ -4025,7 +4025,7 @@
         </p:nvSpPr>
         <p:spPr>
           <a:xfrm>
-            <a:off x="2409190" y="866140"/>
+            <a:off x="2409190" y="815340"/>
             <a:ext cx="45720" cy="45720"/>
           </a:xfrm>
           <a:prstGeom prst="ellipse">
@@ -4075,7 +4075,7 @@
         </p:blipFill>
         <p:spPr>
           <a:xfrm>
-            <a:off x="139700" y="1047750"/>
+            <a:off x="139700" y="971550"/>
             <a:ext cx="139700" cy="139700"/>
           </a:xfrm>
           <a:prstGeom prst="rect">
@@ -4091,7 +4091,7 @@
         </p:nvSpPr>
         <p:spPr>
           <a:xfrm>
-            <a:off x="317500" y="1032001"/>
+            <a:off x="317500" y="955801"/>
             <a:ext cx="549217" cy="135127"/>
           </a:xfrm>
           <a:prstGeom prst="rect">
@@ -4126,7 +4126,7 @@
         </p:nvSpPr>
         <p:spPr>
           <a:xfrm>
-            <a:off x="317500" y="1139571"/>
+            <a:off x="317500" y="1053211"/>
             <a:ext cx="787348" cy="129793"/>
           </a:xfrm>
           <a:prstGeom prst="rect">
@@ -4161,7 +4161,7 @@
         </p:nvSpPr>
         <p:spPr>
           <a:xfrm>
-            <a:off x="1079500" y="1047750"/>
+            <a:off x="1079500" y="971550"/>
             <a:ext cx="457200" cy="177800"/>
           </a:xfrm>
           <a:prstGeom prst="roundRect">
@@ -4207,7 +4207,7 @@
         </p:nvSpPr>
         <p:spPr>
           <a:xfrm>
-            <a:off x="1104900" y="1073150"/>
+            <a:off x="1104900" y="996950"/>
             <a:ext cx="127000" cy="127000"/>
           </a:xfrm>
           <a:prstGeom prst="ellipse">
@@ -4251,7 +4251,7 @@
         </p:nvSpPr>
         <p:spPr>
           <a:xfrm>
-            <a:off x="1073453" y="1089533"/>
+            <a:off x="1073453" y="1013333"/>
             <a:ext cx="189892" cy="122682"/>
           </a:xfrm>
           <a:prstGeom prst="rect">
@@ -4286,7 +4286,7 @@
         </p:nvSpPr>
         <p:spPr>
           <a:xfrm>
-            <a:off x="1266190" y="1113790"/>
+            <a:off x="1266190" y="1037590"/>
             <a:ext cx="45720" cy="45720"/>
           </a:xfrm>
           <a:prstGeom prst="ellipse">
@@ -4328,7 +4328,7 @@
         </p:nvSpPr>
         <p:spPr>
           <a:xfrm>
-            <a:off x="1336040" y="1113790"/>
+            <a:off x="1336040" y="1037590"/>
             <a:ext cx="45720" cy="45720"/>
           </a:xfrm>
           <a:prstGeom prst="ellipse">
@@ -4370,7 +4370,7 @@
         </p:nvCxnSpPr>
         <p:spPr>
           <a:xfrm>
-            <a:off x="1551940" y="1136650"/>
+            <a:off x="1551940" y="1060450"/>
             <a:ext cx="83820" cy="0"/>
           </a:xfrm>
           <a:prstGeom prst="line">
@@ -4407,7 +4407,7 @@
         </p:nvSpPr>
         <p:spPr>
           <a:xfrm>
-            <a:off x="1651000" y="1047750"/>
+            <a:off x="1651000" y="971550"/>
             <a:ext cx="457200" cy="177800"/>
           </a:xfrm>
           <a:prstGeom prst="roundRect">
@@ -4453,7 +4453,7 @@
         </p:nvSpPr>
         <p:spPr>
           <a:xfrm>
-            <a:off x="1691639" y="1113790"/>
+            <a:off x="1691639" y="1037590"/>
             <a:ext cx="45720" cy="45720"/>
           </a:xfrm>
           <a:prstGeom prst="ellipse">
@@ -4495,7 +4495,7 @@
         </p:nvCxnSpPr>
         <p:spPr>
           <a:xfrm>
-            <a:off x="2123440" y="1136650"/>
+            <a:off x="2123440" y="1060450"/>
             <a:ext cx="83820" cy="0"/>
           </a:xfrm>
           <a:prstGeom prst="line">
@@ -4532,7 +4532,7 @@
         </p:nvSpPr>
         <p:spPr>
           <a:xfrm>
-            <a:off x="2222500" y="1047750"/>
+            <a:off x="2222500" y="971550"/>
             <a:ext cx="457200" cy="177800"/>
           </a:xfrm>
           <a:prstGeom prst="roundRect">
@@ -4578,7 +4578,7 @@
         </p:nvSpPr>
         <p:spPr>
           <a:xfrm>
-            <a:off x="2247900" y="1073150"/>
+            <a:off x="2247900" y="996950"/>
             <a:ext cx="127000" cy="127000"/>
           </a:xfrm>
           <a:prstGeom prst="ellipse">
@@ -4622,7 +4622,7 @@
         </p:nvSpPr>
         <p:spPr>
           <a:xfrm>
-            <a:off x="2216402" y="1089533"/>
+            <a:off x="2216402" y="1013333"/>
             <a:ext cx="189995" cy="122682"/>
           </a:xfrm>
           <a:prstGeom prst="rect">
@@ -4665,7 +4665,7 @@
         </p:blipFill>
         <p:spPr>
           <a:xfrm>
-            <a:off x="139700" y="1295400"/>
+            <a:off x="139700" y="1193800"/>
             <a:ext cx="139700" cy="139700"/>
           </a:xfrm>
           <a:prstGeom prst="rect">
@@ -4681,7 +4681,7 @@
         </p:nvSpPr>
         <p:spPr>
           <a:xfrm>
-            <a:off x="317500" y="1279652"/>
+            <a:off x="317500" y="1178052"/>
             <a:ext cx="593768" cy="135127"/>
           </a:xfrm>
           <a:prstGeom prst="rect">
@@ -4716,7 +4716,7 @@
         </p:nvSpPr>
         <p:spPr>
           <a:xfrm>
-            <a:off x="317500" y="1387221"/>
+            <a:off x="317500" y="1275461"/>
             <a:ext cx="698916" cy="129793"/>
           </a:xfrm>
           <a:prstGeom prst="rect">
@@ -4751,7 +4751,7 @@
         </p:nvSpPr>
         <p:spPr>
           <a:xfrm>
-            <a:off x="1079500" y="1295400"/>
+            <a:off x="1079500" y="1193800"/>
             <a:ext cx="457200" cy="177800"/>
           </a:xfrm>
           <a:prstGeom prst="roundRect">
@@ -4797,7 +4797,7 @@
         </p:nvSpPr>
         <p:spPr>
           <a:xfrm>
-            <a:off x="1104900" y="1320800"/>
+            <a:off x="1104900" y="1219200"/>
             <a:ext cx="127000" cy="127000"/>
           </a:xfrm>
           <a:prstGeom prst="ellipse">
@@ -4841,7 +4841,7 @@
         </p:nvSpPr>
         <p:spPr>
           <a:xfrm>
-            <a:off x="1073402" y="1337183"/>
+            <a:off x="1073402" y="1235583"/>
             <a:ext cx="189995" cy="122682"/>
           </a:xfrm>
           <a:prstGeom prst="rect">
@@ -4876,7 +4876,7 @@
         </p:nvSpPr>
         <p:spPr>
           <a:xfrm>
-            <a:off x="1250950" y="1320800"/>
+            <a:off x="1250950" y="1219200"/>
             <a:ext cx="127000" cy="127000"/>
           </a:xfrm>
           <a:prstGeom prst="ellipse">
@@ -4920,7 +4920,7 @@
         </p:nvSpPr>
         <p:spPr>
           <a:xfrm>
-            <a:off x="1219503" y="1337183"/>
+            <a:off x="1219503" y="1235583"/>
             <a:ext cx="189892" cy="122682"/>
           </a:xfrm>
           <a:prstGeom prst="rect">
@@ -4955,7 +4955,7 @@
         </p:nvCxnSpPr>
         <p:spPr>
           <a:xfrm>
-            <a:off x="1551940" y="1384300"/>
+            <a:off x="1551940" y="1282700"/>
             <a:ext cx="83820" cy="0"/>
           </a:xfrm>
           <a:prstGeom prst="line">
@@ -4992,7 +4992,7 @@
         </p:nvSpPr>
         <p:spPr>
           <a:xfrm>
-            <a:off x="1651000" y="1295400"/>
+            <a:off x="1651000" y="1193800"/>
             <a:ext cx="457200" cy="177800"/>
           </a:xfrm>
           <a:prstGeom prst="roundRect">
@@ -5038,7 +5038,7 @@
         </p:nvSpPr>
         <p:spPr>
           <a:xfrm>
-            <a:off x="1691639" y="1361440"/>
+            <a:off x="1691639" y="1259840"/>
             <a:ext cx="45720" cy="45720"/>
           </a:xfrm>
           <a:prstGeom prst="ellipse">
@@ -5080,7 +5080,7 @@
         </p:nvSpPr>
         <p:spPr>
           <a:xfrm>
-            <a:off x="1761489" y="1361440"/>
+            <a:off x="1761489" y="1259840"/>
             <a:ext cx="45720" cy="45720"/>
           </a:xfrm>
           <a:prstGeom prst="ellipse">
@@ -5122,7 +5122,7 @@
         </p:nvSpPr>
         <p:spPr>
           <a:xfrm>
-            <a:off x="1831339" y="1361440"/>
+            <a:off x="1831339" y="1259840"/>
             <a:ext cx="45720" cy="45720"/>
           </a:xfrm>
           <a:prstGeom prst="ellipse">
@@ -5172,7 +5172,7 @@
         </p:blipFill>
         <p:spPr>
           <a:xfrm>
-            <a:off x="139700" y="1543050"/>
+            <a:off x="139700" y="1416050"/>
             <a:ext cx="139700" cy="139700"/>
           </a:xfrm>
           <a:prstGeom prst="rect">
@@ -5188,7 +5188,7 @@
         </p:nvSpPr>
         <p:spPr>
           <a:xfrm>
-            <a:off x="317500" y="1527302"/>
+            <a:off x="317500" y="1400302"/>
             <a:ext cx="593768" cy="135127"/>
           </a:xfrm>
           <a:prstGeom prst="rect">
@@ -5223,7 +5223,7 @@
         </p:nvSpPr>
         <p:spPr>
           <a:xfrm>
-            <a:off x="317500" y="1634871"/>
+            <a:off x="317500" y="1497711"/>
             <a:ext cx="725177" cy="129793"/>
           </a:xfrm>
           <a:prstGeom prst="rect">
@@ -5258,7 +5258,7 @@
         </p:nvSpPr>
         <p:spPr>
           <a:xfrm>
-            <a:off x="1079500" y="1543050"/>
+            <a:off x="1079500" y="1416050"/>
             <a:ext cx="457200" cy="177800"/>
           </a:xfrm>
           <a:prstGeom prst="roundRect">
@@ -5304,7 +5304,7 @@
         </p:nvSpPr>
         <p:spPr>
           <a:xfrm>
-            <a:off x="1104900" y="1568450"/>
+            <a:off x="1104900" y="1441450"/>
             <a:ext cx="127000" cy="127000"/>
           </a:xfrm>
           <a:prstGeom prst="ellipse">
@@ -5348,7 +5348,7 @@
         </p:nvSpPr>
         <p:spPr>
           <a:xfrm>
-            <a:off x="1073402" y="1584833"/>
+            <a:off x="1073402" y="1457833"/>
             <a:ext cx="189995" cy="122682"/>
           </a:xfrm>
           <a:prstGeom prst="rect">
@@ -5383,7 +5383,7 @@
         </p:nvCxnSpPr>
         <p:spPr>
           <a:xfrm>
-            <a:off x="1551940" y="1631950"/>
+            <a:off x="1551940" y="1504950"/>
             <a:ext cx="83820" cy="0"/>
           </a:xfrm>
           <a:prstGeom prst="line">
@@ -5420,7 +5420,7 @@
         </p:nvSpPr>
         <p:spPr>
           <a:xfrm>
-            <a:off x="1651000" y="1543050"/>
+            <a:off x="1651000" y="1416050"/>
             <a:ext cx="457200" cy="177800"/>
           </a:xfrm>
           <a:prstGeom prst="roundRect">
@@ -5466,7 +5466,7 @@
         </p:nvSpPr>
         <p:spPr>
           <a:xfrm>
-            <a:off x="1691639" y="1609090"/>
+            <a:off x="1691639" y="1482090"/>
             <a:ext cx="45720" cy="45720"/>
           </a:xfrm>
           <a:prstGeom prst="ellipse">
@@ -5508,7 +5508,7 @@
         </p:nvSpPr>
         <p:spPr>
           <a:xfrm>
-            <a:off x="1761489" y="1609090"/>
+            <a:off x="1761489" y="1482090"/>
             <a:ext cx="45720" cy="45720"/>
           </a:xfrm>
           <a:prstGeom prst="ellipse">
@@ -5550,7 +5550,7 @@
         </p:nvSpPr>
         <p:spPr>
           <a:xfrm>
-            <a:off x="1831339" y="1609090"/>
+            <a:off x="1831339" y="1482090"/>
             <a:ext cx="45720" cy="45720"/>
           </a:xfrm>
           <a:prstGeom prst="ellipse">
@@ -5592,7 +5592,7 @@
         </p:nvSpPr>
         <p:spPr>
           <a:xfrm>
-            <a:off x="137160" y="1742440"/>
+            <a:off x="137160" y="1615440"/>
             <a:ext cx="106680" cy="106680"/>
           </a:xfrm>
           <a:prstGeom prst="ellipse">
@@ -5636,7 +5636,7 @@
         </p:nvSpPr>
         <p:spPr>
           <a:xfrm>
-            <a:off x="98700" y="1754123"/>
+            <a:off x="98700" y="1627123"/>
             <a:ext cx="183598" cy="110236"/>
           </a:xfrm>
           <a:prstGeom prst="rect">
@@ -5671,7 +5671,7 @@
         </p:nvSpPr>
         <p:spPr>
           <a:xfrm>
-            <a:off x="279400" y="1745361"/>
+            <a:off x="279400" y="1618361"/>
             <a:ext cx="461714" cy="129793"/>
           </a:xfrm>
           <a:prstGeom prst="rect">
@@ -5706,7 +5706,7 @@
         </p:nvSpPr>
         <p:spPr>
           <a:xfrm>
-            <a:off x="521632" y="1742440"/>
+            <a:off x="521632" y="1615440"/>
             <a:ext cx="106680" cy="106680"/>
           </a:xfrm>
           <a:prstGeom prst="ellipse">
@@ -5750,7 +5750,7 @@
         </p:nvSpPr>
         <p:spPr>
           <a:xfrm>
-            <a:off x="483225" y="1754123"/>
+            <a:off x="483225" y="1627123"/>
             <a:ext cx="183495" cy="110236"/>
           </a:xfrm>
           <a:prstGeom prst="rect">
@@ -5785,7 +5785,7 @@
         </p:nvSpPr>
         <p:spPr>
           <a:xfrm>
-            <a:off x="663872" y="1745361"/>
+            <a:off x="663872" y="1618361"/>
             <a:ext cx="675957" cy="129793"/>
           </a:xfrm>
           <a:prstGeom prst="rect">
@@ -5820,7 +5820,7 @@
         </p:nvSpPr>
         <p:spPr>
           <a:xfrm>
-            <a:off x="1088687" y="1772920"/>
+            <a:off x="1088687" y="1645920"/>
             <a:ext cx="45720" cy="45720"/>
           </a:xfrm>
           <a:prstGeom prst="ellipse">
@@ -5862,7 +5862,7 @@
         </p:nvSpPr>
         <p:spPr>
           <a:xfrm>
-            <a:off x="1175047" y="1745361"/>
+            <a:off x="1175047" y="1618361"/>
             <a:ext cx="1835991" cy="129793"/>
           </a:xfrm>
           <a:prstGeom prst="rect">
@@ -5897,7 +5897,7 @@
         </p:nvSpPr>
         <p:spPr>
           <a:xfrm>
-            <a:off x="139700" y="1923795"/>
+            <a:off x="139700" y="1784095"/>
             <a:ext cx="2674106" cy="138683"/>
           </a:xfrm>
           <a:prstGeom prst="rect">
@@ -5941,7 +5941,7 @@
         </p:nvSpPr>
         <p:spPr>
           <a:xfrm>
-            <a:off x="139700" y="2197100"/>
+            <a:off x="139700" y="2044700"/>
             <a:ext cx="92286" cy="114300"/>
           </a:xfrm>
           <a:prstGeom prst="rect">
@@ -5985,7 +5985,7 @@
         </p:nvSpPr>
         <p:spPr>
           <a:xfrm>
-            <a:off x="231986" y="2197100"/>
+            <a:off x="231986" y="2044700"/>
             <a:ext cx="92286" cy="114300"/>
           </a:xfrm>
           <a:prstGeom prst="rect">
@@ -6029,7 +6029,7 @@
         </p:nvSpPr>
         <p:spPr>
           <a:xfrm>
-            <a:off x="324273" y="2197100"/>
+            <a:off x="324273" y="2044700"/>
             <a:ext cx="92286" cy="114300"/>
           </a:xfrm>
           <a:prstGeom prst="rect">
@@ -6073,7 +6073,7 @@
         </p:nvSpPr>
         <p:spPr>
           <a:xfrm>
-            <a:off x="416559" y="2197100"/>
+            <a:off x="416559" y="2044700"/>
             <a:ext cx="92286" cy="114300"/>
           </a:xfrm>
           <a:prstGeom prst="rect">
@@ -6117,7 +6117,7 @@
         </p:nvSpPr>
         <p:spPr>
           <a:xfrm>
-            <a:off x="508846" y="2197100"/>
+            <a:off x="508846" y="2044700"/>
             <a:ext cx="92286" cy="114300"/>
           </a:xfrm>
           <a:prstGeom prst="rect">
@@ -6161,7 +6161,7 @@
         </p:nvSpPr>
         <p:spPr>
           <a:xfrm>
-            <a:off x="601133" y="2197100"/>
+            <a:off x="601133" y="2044700"/>
             <a:ext cx="92286" cy="114300"/>
           </a:xfrm>
           <a:prstGeom prst="rect">
@@ -6205,7 +6205,7 @@
         </p:nvSpPr>
         <p:spPr>
           <a:xfrm>
-            <a:off x="693420" y="2197100"/>
+            <a:off x="693420" y="2044700"/>
             <a:ext cx="92286" cy="114300"/>
           </a:xfrm>
           <a:prstGeom prst="rect">
@@ -6249,7 +6249,7 @@
         </p:nvSpPr>
         <p:spPr>
           <a:xfrm>
-            <a:off x="785706" y="2197100"/>
+            <a:off x="785706" y="2044700"/>
             <a:ext cx="92286" cy="114300"/>
           </a:xfrm>
           <a:prstGeom prst="rect">
@@ -6293,7 +6293,7 @@
         </p:nvSpPr>
         <p:spPr>
           <a:xfrm>
-            <a:off x="877993" y="2197100"/>
+            <a:off x="877993" y="2044700"/>
             <a:ext cx="92286" cy="114300"/>
           </a:xfrm>
           <a:prstGeom prst="rect">
@@ -6337,7 +6337,7 @@
         </p:nvSpPr>
         <p:spPr>
           <a:xfrm>
-            <a:off x="970280" y="2197100"/>
+            <a:off x="970280" y="2044700"/>
             <a:ext cx="92286" cy="114300"/>
           </a:xfrm>
           <a:prstGeom prst="rect">
@@ -6381,7 +6381,7 @@
         </p:nvSpPr>
         <p:spPr>
           <a:xfrm>
-            <a:off x="1062566" y="2197100"/>
+            <a:off x="1062566" y="2044700"/>
             <a:ext cx="92286" cy="114300"/>
           </a:xfrm>
           <a:prstGeom prst="rect">
@@ -6425,7 +6425,7 @@
         </p:nvSpPr>
         <p:spPr>
           <a:xfrm>
-            <a:off x="1154853" y="2197100"/>
+            <a:off x="1154853" y="2044700"/>
             <a:ext cx="92286" cy="114300"/>
           </a:xfrm>
           <a:prstGeom prst="rect">
@@ -6469,7 +6469,7 @@
         </p:nvSpPr>
         <p:spPr>
           <a:xfrm>
-            <a:off x="1247140" y="2197100"/>
+            <a:off x="1247140" y="2044700"/>
             <a:ext cx="92286" cy="114300"/>
           </a:xfrm>
           <a:prstGeom prst="rect">
@@ -6513,7 +6513,7 @@
         </p:nvSpPr>
         <p:spPr>
           <a:xfrm>
-            <a:off x="1339426" y="2197100"/>
+            <a:off x="1339426" y="2044700"/>
             <a:ext cx="92286" cy="114300"/>
           </a:xfrm>
           <a:prstGeom prst="rect">
@@ -6557,7 +6557,7 @@
         </p:nvSpPr>
         <p:spPr>
           <a:xfrm>
-            <a:off x="1431713" y="2197100"/>
+            <a:off x="1431713" y="2044700"/>
             <a:ext cx="92286" cy="114300"/>
           </a:xfrm>
           <a:prstGeom prst="rect">
@@ -6601,7 +6601,7 @@
         </p:nvSpPr>
         <p:spPr>
           <a:xfrm>
-            <a:off x="1524000" y="2197100"/>
+            <a:off x="1524000" y="2044700"/>
             <a:ext cx="92286" cy="114300"/>
           </a:xfrm>
           <a:prstGeom prst="rect">
@@ -6645,7 +6645,7 @@
         </p:nvSpPr>
         <p:spPr>
           <a:xfrm>
-            <a:off x="1616286" y="2197100"/>
+            <a:off x="1616286" y="2044700"/>
             <a:ext cx="92286" cy="114300"/>
           </a:xfrm>
           <a:prstGeom prst="rect">
@@ -6689,7 +6689,7 @@
         </p:nvSpPr>
         <p:spPr>
           <a:xfrm>
-            <a:off x="1708573" y="2197100"/>
+            <a:off x="1708573" y="2044700"/>
             <a:ext cx="92286" cy="114300"/>
           </a:xfrm>
           <a:prstGeom prst="rect">
@@ -6733,7 +6733,7 @@
         </p:nvSpPr>
         <p:spPr>
           <a:xfrm>
-            <a:off x="1800860" y="2197100"/>
+            <a:off x="1800860" y="2044700"/>
             <a:ext cx="92286" cy="114300"/>
           </a:xfrm>
           <a:prstGeom prst="rect">
@@ -6777,7 +6777,7 @@
         </p:nvSpPr>
         <p:spPr>
           <a:xfrm>
-            <a:off x="1893146" y="2197100"/>
+            <a:off x="1893146" y="2044700"/>
             <a:ext cx="92286" cy="114300"/>
           </a:xfrm>
           <a:prstGeom prst="rect">
@@ -6821,7 +6821,7 @@
         </p:nvSpPr>
         <p:spPr>
           <a:xfrm>
-            <a:off x="1985433" y="2197100"/>
+            <a:off x="1985433" y="2044700"/>
             <a:ext cx="92286" cy="114300"/>
           </a:xfrm>
           <a:prstGeom prst="rect">
@@ -6865,7 +6865,7 @@
         </p:nvSpPr>
         <p:spPr>
           <a:xfrm>
-            <a:off x="2077720" y="2197100"/>
+            <a:off x="2077720" y="2044700"/>
             <a:ext cx="92286" cy="114300"/>
           </a:xfrm>
           <a:prstGeom prst="rect">
@@ -6909,7 +6909,7 @@
         </p:nvSpPr>
         <p:spPr>
           <a:xfrm>
-            <a:off x="2170006" y="2197100"/>
+            <a:off x="2170006" y="2044700"/>
             <a:ext cx="92286" cy="114300"/>
           </a:xfrm>
           <a:prstGeom prst="rect">
@@ -6953,7 +6953,7 @@
         </p:nvSpPr>
         <p:spPr>
           <a:xfrm>
-            <a:off x="2262293" y="2197100"/>
+            <a:off x="2262293" y="2044700"/>
             <a:ext cx="92286" cy="114300"/>
           </a:xfrm>
           <a:prstGeom prst="rect">
@@ -6997,7 +6997,7 @@
         </p:nvSpPr>
         <p:spPr>
           <a:xfrm>
-            <a:off x="2354580" y="2197100"/>
+            <a:off x="2354580" y="2044700"/>
             <a:ext cx="92286" cy="114300"/>
           </a:xfrm>
           <a:prstGeom prst="rect">
@@ -7041,7 +7041,7 @@
         </p:nvSpPr>
         <p:spPr>
           <a:xfrm>
-            <a:off x="2446866" y="2197100"/>
+            <a:off x="2446866" y="2044700"/>
             <a:ext cx="92286" cy="114300"/>
           </a:xfrm>
           <a:prstGeom prst="rect">
@@ -7085,7 +7085,7 @@
         </p:nvSpPr>
         <p:spPr>
           <a:xfrm>
-            <a:off x="2539153" y="2197100"/>
+            <a:off x="2539153" y="2044700"/>
             <a:ext cx="92286" cy="114300"/>
           </a:xfrm>
           <a:prstGeom prst="rect">
@@ -7129,7 +7129,7 @@
         </p:nvSpPr>
         <p:spPr>
           <a:xfrm>
-            <a:off x="2631440" y="2197100"/>
+            <a:off x="2631440" y="2044700"/>
             <a:ext cx="92286" cy="114300"/>
           </a:xfrm>
           <a:prstGeom prst="rect">
@@ -7173,7 +7173,7 @@
         </p:nvSpPr>
         <p:spPr>
           <a:xfrm>
-            <a:off x="2723726" y="2197100"/>
+            <a:off x="2723726" y="2044700"/>
             <a:ext cx="92286" cy="114300"/>
           </a:xfrm>
           <a:prstGeom prst="rect">
@@ -7217,7 +7217,7 @@
         </p:nvSpPr>
         <p:spPr>
           <a:xfrm>
-            <a:off x="2816013" y="2197100"/>
+            <a:off x="2816013" y="2044700"/>
             <a:ext cx="92286" cy="114300"/>
           </a:xfrm>
           <a:prstGeom prst="rect">
@@ -7261,7 +7261,7 @@
         </p:nvSpPr>
         <p:spPr>
           <a:xfrm>
-            <a:off x="139700" y="2197100"/>
+            <a:off x="139700" y="2044700"/>
             <a:ext cx="2768600" cy="114300"/>
           </a:xfrm>
           <a:prstGeom prst="rect">
@@ -7303,7 +7303,7 @@
         </p:nvSpPr>
         <p:spPr>
           <a:xfrm>
-            <a:off x="152400" y="2146300"/>
+            <a:off x="152400" y="1993900"/>
             <a:ext cx="2006600" cy="38100"/>
           </a:xfrm>
           <a:custGeom>
@@ -7365,7 +7365,7 @@
         </p:nvSpPr>
         <p:spPr>
           <a:xfrm>
-            <a:off x="500050" y="2038604"/>
+            <a:off x="500050" y="1886204"/>
             <a:ext cx="1309606" cy="128015"/>
           </a:xfrm>
           <a:prstGeom prst="rect">
@@ -7400,7 +7400,7 @@
         </p:nvSpPr>
         <p:spPr>
           <a:xfrm>
-            <a:off x="2184400" y="2146300"/>
+            <a:off x="2184400" y="1993900"/>
             <a:ext cx="711200" cy="38100"/>
           </a:xfrm>
           <a:custGeom>
@@ -7462,7 +7462,7 @@
         </p:nvSpPr>
         <p:spPr>
           <a:xfrm>
-            <a:off x="2135702" y="2038604"/>
+            <a:off x="2135702" y="1886204"/>
             <a:ext cx="806902" cy="128015"/>
           </a:xfrm>
           <a:prstGeom prst="rect">
@@ -7497,7 +7497,7 @@
         </p:nvSpPr>
         <p:spPr>
           <a:xfrm>
-            <a:off x="152400" y="2324100"/>
+            <a:off x="152400" y="2171700"/>
             <a:ext cx="1638300" cy="38100"/>
           </a:xfrm>
           <a:custGeom>
@@ -7559,7 +7559,7 @@
         </p:nvSpPr>
         <p:spPr>
           <a:xfrm>
-            <a:off x="487490" y="2373884"/>
+            <a:off x="487490" y="2221484"/>
             <a:ext cx="965579" cy="128015"/>
           </a:xfrm>
           <a:prstGeom prst="rect">
@@ -7594,7 +7594,7 @@
         </p:nvSpPr>
         <p:spPr>
           <a:xfrm>
-            <a:off x="1803400" y="2324100"/>
+            <a:off x="1803400" y="2171700"/>
             <a:ext cx="355600" cy="38100"/>
           </a:xfrm>
           <a:custGeom>
@@ -7656,7 +7656,7 @@
         </p:nvSpPr>
         <p:spPr>
           <a:xfrm>
-            <a:off x="1704414" y="2373884"/>
+            <a:off x="1704414" y="2221484"/>
             <a:ext cx="562038" cy="128015"/>
           </a:xfrm>
           <a:prstGeom prst="rect">
@@ -7691,8 +7691,8 @@
         </p:nvSpPr>
         <p:spPr>
           <a:xfrm>
-            <a:off x="63500" y="2603500"/>
-            <a:ext cx="2921000" cy="889000"/>
+            <a:off x="63500" y="2413000"/>
+            <a:ext cx="2921000" cy="774700"/>
           </a:xfrm>
           <a:prstGeom prst="rect">
             <a:avLst/>
@@ -7735,7 +7735,7 @@
         </p:nvSpPr>
         <p:spPr>
           <a:xfrm>
-            <a:off x="127000" y="2614930"/>
+            <a:off x="127000" y="2424430"/>
             <a:ext cx="1342470" cy="191770"/>
           </a:xfrm>
           <a:prstGeom prst="rect">
@@ -7779,7 +7779,7 @@
         </p:nvSpPr>
         <p:spPr>
           <a:xfrm>
-            <a:off x="184150" y="2660944"/>
+            <a:off x="184150" y="2470444"/>
             <a:ext cx="1449425" cy="170688"/>
           </a:xfrm>
           <a:prstGeom prst="rect">
@@ -7822,8 +7822,8 @@
         </p:blipFill>
         <p:spPr>
           <a:xfrm>
-            <a:off x="139700" y="2870200"/>
-            <a:ext cx="279400" cy="279400"/>
+            <a:off x="139700" y="2654300"/>
+            <a:ext cx="254000" cy="254000"/>
           </a:xfrm>
           <a:prstGeom prst="rect">
             <a:avLst/>
@@ -7838,8 +7838,8 @@
         </p:nvSpPr>
         <p:spPr>
           <a:xfrm>
-            <a:off x="431800" y="2870200"/>
-            <a:ext cx="2476500" cy="215900"/>
+            <a:off x="406400" y="2654300"/>
+            <a:ext cx="2501900" cy="203200"/>
           </a:xfrm>
           <a:custGeom>
             <a:avLst/>
@@ -7848,66 +7848,66 @@
             <a:cxnLst/>
             <a:rect l="l" t="t" r="r" b="b"/>
             <a:pathLst>
-              <a:path w="195" h="17">
+              <a:path w="197" h="16">
                 <a:moveTo>
                   <a:pt x="12" y="0"/>
                 </a:moveTo>
                 <a:lnTo>
-                  <a:pt x="188" y="0"/>
+                  <a:pt x="190" y="0"/>
                 </a:lnTo>
                 <a:lnTo>
-                  <a:pt x="191" y="0"/>
+                  <a:pt x="193" y="0"/>
                 </a:lnTo>
                 <a:lnTo>
-                  <a:pt x="192" y="1"/>
+                  <a:pt x="194" y="1"/>
                 </a:lnTo>
                 <a:lnTo>
-                  <a:pt x="194" y="3"/>
+                  <a:pt x="196" y="3"/>
                 </a:lnTo>
                 <a:lnTo>
-                  <a:pt x="195" y="4"/>
+                  <a:pt x="197" y="4"/>
                 </a:lnTo>
                 <a:lnTo>
-                  <a:pt x="195" y="7"/>
+                  <a:pt x="197" y="7"/>
                 </a:lnTo>
                 <a:lnTo>
-                  <a:pt x="195" y="10"/>
+                  <a:pt x="197" y="9"/>
                 </a:lnTo>
                 <a:lnTo>
-                  <a:pt x="195" y="13"/>
+                  <a:pt x="197" y="12"/>
                 </a:lnTo>
                 <a:lnTo>
-                  <a:pt x="194" y="14"/>
+                  <a:pt x="196" y="13"/>
                 </a:lnTo>
                 <a:lnTo>
-                  <a:pt x="192" y="16"/>
+                  <a:pt x="194" y="15"/>
                 </a:lnTo>
                 <a:lnTo>
-                  <a:pt x="191" y="17"/>
+                  <a:pt x="193" y="16"/>
                 </a:lnTo>
                 <a:lnTo>
-                  <a:pt x="188" y="17"/>
+                  <a:pt x="190" y="16"/>
                 </a:lnTo>
                 <a:lnTo>
-                  <a:pt x="12" y="17"/>
+                  <a:pt x="12" y="16"/>
                 </a:lnTo>
                 <a:lnTo>
-                  <a:pt x="9" y="17"/>
+                  <a:pt x="9" y="16"/>
                 </a:lnTo>
                 <a:lnTo>
-                  <a:pt x="8" y="16"/>
+                  <a:pt x="8" y="15"/>
                 </a:lnTo>
                 <a:lnTo>
-                  <a:pt x="6" y="14"/>
+                  <a:pt x="6" y="13"/>
                 </a:lnTo>
                 <a:lnTo>
-                  <a:pt x="5" y="13"/>
+                  <a:pt x="5" y="12"/>
+                </a:lnTo>
+                <a:lnTo>
+                  <a:pt x="5" y="9"/>
                 </a:lnTo>
                 <a:lnTo>
                   <a:pt x="5" y="10"/>
-                </a:lnTo>
-                <a:lnTo>
-                  <a:pt x="5" y="11"/>
                 </a:lnTo>
                 <a:lnTo>
                   <a:pt x="0" y="9"/>
@@ -7975,7 +7975,7 @@
         </p:nvSpPr>
         <p:spPr>
           <a:xfrm>
-            <a:off x="584200" y="2918714"/>
+            <a:off x="558800" y="2696464"/>
             <a:ext cx="2552164" cy="145795"/>
           </a:xfrm>
           <a:prstGeom prst="rect">
@@ -8028,7 +8028,7 @@
         </p:nvSpPr>
         <p:spPr>
           <a:xfrm>
-            <a:off x="139700" y="3162300"/>
+            <a:off x="139700" y="2895600"/>
             <a:ext cx="741259" cy="152400"/>
           </a:xfrm>
           <a:prstGeom prst="roundRect">
@@ -8074,7 +8074,7 @@
         </p:nvSpPr>
         <p:spPr>
           <a:xfrm>
-            <a:off x="190500" y="3182264"/>
+            <a:off x="190500" y="2915564"/>
             <a:ext cx="904156" cy="145795"/>
           </a:xfrm>
           <a:prstGeom prst="rect">
@@ -8109,7 +8109,7 @@
         </p:nvCxnSpPr>
         <p:spPr>
           <a:xfrm>
-            <a:off x="900009" y="3238500"/>
+            <a:off x="900009" y="2971800"/>
             <a:ext cx="76200" cy="0"/>
           </a:xfrm>
           <a:prstGeom prst="line">
@@ -8146,7 +8146,7 @@
         </p:nvSpPr>
         <p:spPr>
           <a:xfrm>
-            <a:off x="995259" y="3162300"/>
+            <a:off x="995259" y="2895600"/>
             <a:ext cx="605218" cy="152400"/>
           </a:xfrm>
           <a:prstGeom prst="roundRect">
@@ -8192,7 +8192,7 @@
         </p:nvSpPr>
         <p:spPr>
           <a:xfrm>
-            <a:off x="1046059" y="3182264"/>
+            <a:off x="1046059" y="2915564"/>
             <a:ext cx="762635" cy="145795"/>
           </a:xfrm>
           <a:prstGeom prst="rect">
@@ -8227,7 +8227,7 @@
         </p:nvCxnSpPr>
         <p:spPr>
           <a:xfrm>
-            <a:off x="1619528" y="3238500"/>
+            <a:off x="1619528" y="2971800"/>
             <a:ext cx="76200" cy="0"/>
           </a:xfrm>
           <a:prstGeom prst="line">
@@ -8264,7 +8264,7 @@
         </p:nvSpPr>
         <p:spPr>
           <a:xfrm>
-            <a:off x="1714778" y="3162300"/>
+            <a:off x="1714778" y="2895600"/>
             <a:ext cx="552424" cy="152400"/>
           </a:xfrm>
           <a:prstGeom prst="roundRect">
@@ -8310,7 +8310,7 @@
         </p:nvSpPr>
         <p:spPr>
           <a:xfrm>
-            <a:off x="1765578" y="3182264"/>
+            <a:off x="1765578" y="2915564"/>
             <a:ext cx="696001" cy="145795"/>
           </a:xfrm>
           <a:prstGeom prst="rect">
@@ -8345,8 +8345,8 @@
         </p:nvSpPr>
         <p:spPr>
           <a:xfrm>
-            <a:off x="2565400" y="3073400"/>
-            <a:ext cx="342900" cy="330200"/>
+            <a:off x="2565400" y="2794000"/>
+            <a:ext cx="342900" cy="342900"/>
           </a:xfrm>
           <a:custGeom>
             <a:avLst/>
@@ -8355,72 +8355,72 @@
             <a:cxnLst/>
             <a:rect l="l" t="t" r="r" b="b"/>
             <a:pathLst>
-              <a:path w="27" h="26">
+              <a:path w="27" h="27">
                 <a:moveTo>
-                  <a:pt x="27" y="16"/>
+                  <a:pt x="27" y="17"/>
                 </a:moveTo>
                 <a:lnTo>
-                  <a:pt x="22" y="17"/>
+                  <a:pt x="22" y="18"/>
                 </a:lnTo>
                 <a:lnTo>
-                  <a:pt x="24" y="22"/>
+                  <a:pt x="24" y="23"/>
                 </a:lnTo>
                 <a:lnTo>
-                  <a:pt x="18" y="20"/>
+                  <a:pt x="18" y="21"/>
                 </a:lnTo>
                 <a:lnTo>
-                  <a:pt x="17" y="26"/>
+                  <a:pt x="17" y="27"/>
                 </a:lnTo>
                 <a:lnTo>
                   <a:pt x="14" y="22"/>
                 </a:lnTo>
                 <a:lnTo>
-                  <a:pt x="10" y="26"/>
+                  <a:pt x="10" y="27"/>
                 </a:lnTo>
                 <a:lnTo>
-                  <a:pt x="9" y="20"/>
+                  <a:pt x="9" y="21"/>
                 </a:lnTo>
                 <a:lnTo>
-                  <a:pt x="3" y="21"/>
+                  <a:pt x="3" y="22"/>
                 </a:lnTo>
                 <a:lnTo>
-                  <a:pt x="6" y="16"/>
+                  <a:pt x="6" y="17"/>
                 </a:lnTo>
                 <a:lnTo>
-                  <a:pt x="0" y="14"/>
+                  <a:pt x="0" y="15"/>
                 </a:lnTo>
                 <a:lnTo>
-                  <a:pt x="6" y="11"/>
+                  <a:pt x="6" y="12"/>
                 </a:lnTo>
                 <a:lnTo>
-                  <a:pt x="2" y="7"/>
+                  <a:pt x="2" y="8"/>
                 </a:lnTo>
                 <a:lnTo>
-                  <a:pt x="8" y="7"/>
+                  <a:pt x="8" y="8"/>
                 </a:lnTo>
                 <a:lnTo>
-                  <a:pt x="7" y="1"/>
+                  <a:pt x="7" y="2"/>
                 </a:lnTo>
                 <a:lnTo>
-                  <a:pt x="12" y="5"/>
+                  <a:pt x="12" y="6"/>
                 </a:lnTo>
                 <a:lnTo>
                   <a:pt x="15" y="0"/>
                 </a:lnTo>
                 <a:lnTo>
-                  <a:pt x="17" y="5"/>
+                  <a:pt x="17" y="6"/>
                 </a:lnTo>
                 <a:lnTo>
-                  <a:pt x="22" y="2"/>
+                  <a:pt x="22" y="3"/>
                 </a:lnTo>
                 <a:lnTo>
-                  <a:pt x="21" y="8"/>
+                  <a:pt x="21" y="9"/>
                 </a:lnTo>
                 <a:lnTo>
-                  <a:pt x="27" y="8"/>
+                  <a:pt x="27" y="9"/>
                 </a:lnTo>
                 <a:lnTo>
-                  <a:pt x="22" y="12"/>
+                  <a:pt x="22" y="13"/>
                 </a:lnTo>
                 <a:close/>
               </a:path>
@@ -8464,7 +8464,7 @@
         </p:nvSpPr>
         <p:spPr>
           <a:xfrm>
-            <a:off x="2556287" y="3189130"/>
+            <a:off x="2556287" y="2922430"/>
             <a:ext cx="373824" cy="138684"/>
           </a:xfrm>
           <a:prstGeom prst="rect">
@@ -8499,7 +8499,7 @@
         </p:nvSpPr>
         <p:spPr>
           <a:xfrm>
-            <a:off x="139700" y="3339846"/>
+            <a:off x="139700" y="3054096"/>
             <a:ext cx="2536350" cy="138683"/>
           </a:xfrm>
           <a:prstGeom prst="rect">
@@ -8552,8 +8552,8 @@
         </p:nvSpPr>
         <p:spPr>
           <a:xfrm>
-            <a:off x="63500" y="3556000"/>
-            <a:ext cx="2921000" cy="965200"/>
+            <a:off x="63500" y="3238500"/>
+            <a:ext cx="2921000" cy="825500"/>
           </a:xfrm>
           <a:prstGeom prst="rect">
             <a:avLst/>
@@ -8596,7 +8596,7 @@
         </p:nvSpPr>
         <p:spPr>
           <a:xfrm>
-            <a:off x="127000" y="3567429"/>
+            <a:off x="127000" y="3249929"/>
             <a:ext cx="1248171" cy="191770"/>
           </a:xfrm>
           <a:prstGeom prst="rect">
@@ -8640,7 +8640,7 @@
         </p:nvSpPr>
         <p:spPr>
           <a:xfrm>
-            <a:off x="184150" y="3613444"/>
+            <a:off x="184150" y="3295944"/>
             <a:ext cx="1342032" cy="170688"/>
           </a:xfrm>
           <a:prstGeom prst="rect">
@@ -8683,7 +8683,7 @@
         </p:blipFill>
         <p:spPr>
           <a:xfrm>
-            <a:off x="2692400" y="3594100"/>
+            <a:off x="2692400" y="3276600"/>
             <a:ext cx="203200" cy="203200"/>
           </a:xfrm>
           <a:prstGeom prst="rect">
@@ -8699,12 +8699,12 @@
         </p:nvSpPr>
         <p:spPr>
           <a:xfrm>
-            <a:off x="139700" y="3810000"/>
-            <a:ext cx="855133" cy="635000"/>
+            <a:off x="139700" y="3479800"/>
+            <a:ext cx="855133" cy="533400"/>
           </a:xfrm>
           <a:prstGeom prst="roundRect">
             <a:avLst>
-              <a:gd name="adj" fmla="val 10000"/>
+              <a:gd name="adj" fmla="val 11904"/>
             </a:avLst>
           </a:prstGeom>
           <a:solidFill>
@@ -8745,8 +8745,8 @@
         </p:nvSpPr>
         <p:spPr>
           <a:xfrm>
-            <a:off x="172720" y="3843020"/>
-            <a:ext cx="162560" cy="162560"/>
+            <a:off x="175260" y="3509010"/>
+            <a:ext cx="157480" cy="157480"/>
           </a:xfrm>
           <a:prstGeom prst="ellipse">
             <a:avLst/>
@@ -8787,7 +8787,7 @@
         </p:nvSpPr>
         <p:spPr>
           <a:xfrm>
-            <a:off x="139344" y="3881882"/>
+            <a:off x="139344" y="3544062"/>
             <a:ext cx="229310" cy="117347"/>
           </a:xfrm>
           <a:prstGeom prst="rect">
@@ -8822,7 +8822,7 @@
         </p:nvSpPr>
         <p:spPr>
           <a:xfrm>
-            <a:off x="374650" y="3868420"/>
+            <a:off x="374650" y="3531870"/>
             <a:ext cx="655603" cy="142239"/>
           </a:xfrm>
           <a:prstGeom prst="rect">
@@ -8857,7 +8857,7 @@
         </p:nvSpPr>
         <p:spPr>
           <a:xfrm>
-            <a:off x="203200" y="4032504"/>
+            <a:off x="203200" y="3671824"/>
             <a:ext cx="942851" cy="128015"/>
           </a:xfrm>
           <a:prstGeom prst="rect">
@@ -8892,7 +8892,7 @@
         </p:nvSpPr>
         <p:spPr>
           <a:xfrm>
-            <a:off x="203200" y="4141724"/>
+            <a:off x="203200" y="3775964"/>
             <a:ext cx="900622" cy="128015"/>
           </a:xfrm>
           <a:prstGeom prst="rect">
@@ -8927,7 +8927,7 @@
         </p:nvSpPr>
         <p:spPr>
           <a:xfrm>
-            <a:off x="203200" y="4250944"/>
+            <a:off x="203200" y="3880104"/>
             <a:ext cx="864506" cy="128015"/>
           </a:xfrm>
           <a:prstGeom prst="rect">
@@ -8962,7 +8962,7 @@
         </p:nvCxnSpPr>
         <p:spPr>
           <a:xfrm>
-            <a:off x="1010073" y="4127500"/>
+            <a:off x="1010073" y="3746500"/>
             <a:ext cx="71120" cy="0"/>
           </a:xfrm>
           <a:prstGeom prst="line">
@@ -8999,12 +8999,12 @@
         </p:nvSpPr>
         <p:spPr>
           <a:xfrm>
-            <a:off x="1096433" y="3810000"/>
-            <a:ext cx="855133" cy="635000"/>
+            <a:off x="1096433" y="3479800"/>
+            <a:ext cx="855133" cy="533400"/>
           </a:xfrm>
           <a:prstGeom prst="roundRect">
             <a:avLst>
-              <a:gd name="adj" fmla="val 10000"/>
+              <a:gd name="adj" fmla="val 11904"/>
             </a:avLst>
           </a:prstGeom>
           <a:solidFill>
@@ -9045,8 +9045,8 @@
         </p:nvSpPr>
         <p:spPr>
           <a:xfrm>
-            <a:off x="1129453" y="3843020"/>
-            <a:ext cx="162560" cy="162560"/>
+            <a:off x="1131993" y="3509010"/>
+            <a:ext cx="157480" cy="157480"/>
           </a:xfrm>
           <a:prstGeom prst="ellipse">
             <a:avLst/>
@@ -9087,7 +9087,7 @@
         </p:nvSpPr>
         <p:spPr>
           <a:xfrm>
-            <a:off x="1090351" y="3881882"/>
+            <a:off x="1090351" y="3544062"/>
             <a:ext cx="240764" cy="117347"/>
           </a:xfrm>
           <a:prstGeom prst="rect">
@@ -9122,7 +9122,7 @@
         </p:nvSpPr>
         <p:spPr>
           <a:xfrm>
-            <a:off x="1331383" y="3868420"/>
+            <a:off x="1331383" y="3531870"/>
             <a:ext cx="575401" cy="142239"/>
           </a:xfrm>
           <a:prstGeom prst="rect">
@@ -9157,7 +9157,7 @@
         </p:nvSpPr>
         <p:spPr>
           <a:xfrm>
-            <a:off x="1159933" y="4032504"/>
+            <a:off x="1159933" y="3671824"/>
             <a:ext cx="904904" cy="128015"/>
           </a:xfrm>
           <a:prstGeom prst="rect">
@@ -9192,7 +9192,7 @@
         </p:nvSpPr>
         <p:spPr>
           <a:xfrm>
-            <a:off x="1159933" y="4141724"/>
+            <a:off x="1159933" y="3775964"/>
             <a:ext cx="721824" cy="128015"/>
           </a:xfrm>
           <a:prstGeom prst="rect">
@@ -9227,7 +9227,7 @@
         </p:nvSpPr>
         <p:spPr>
           <a:xfrm>
-            <a:off x="1159933" y="4250944"/>
+            <a:off x="1159933" y="3880104"/>
             <a:ext cx="820213" cy="128015"/>
           </a:xfrm>
           <a:prstGeom prst="rect">
@@ -9262,7 +9262,7 @@
         </p:nvCxnSpPr>
         <p:spPr>
           <a:xfrm>
-            <a:off x="1966806" y="4127500"/>
+            <a:off x="1966806" y="3746500"/>
             <a:ext cx="71120" cy="0"/>
           </a:xfrm>
           <a:prstGeom prst="line">
@@ -9299,12 +9299,12 @@
         </p:nvSpPr>
         <p:spPr>
           <a:xfrm>
-            <a:off x="2053166" y="3810000"/>
-            <a:ext cx="855133" cy="635000"/>
+            <a:off x="2053166" y="3479800"/>
+            <a:ext cx="855133" cy="533400"/>
           </a:xfrm>
           <a:prstGeom prst="roundRect">
             <a:avLst>
-              <a:gd name="adj" fmla="val 10000"/>
+              <a:gd name="adj" fmla="val 11904"/>
             </a:avLst>
           </a:prstGeom>
           <a:solidFill>
@@ -9345,8 +9345,8 @@
         </p:nvSpPr>
         <p:spPr>
           <a:xfrm>
-            <a:off x="2086186" y="3843020"/>
-            <a:ext cx="162560" cy="162560"/>
+            <a:off x="2088726" y="3509010"/>
+            <a:ext cx="157480" cy="157480"/>
           </a:xfrm>
           <a:prstGeom prst="ellipse">
             <a:avLst/>
@@ -9387,7 +9387,7 @@
         </p:nvSpPr>
         <p:spPr>
           <a:xfrm>
-            <a:off x="2047368" y="3881882"/>
+            <a:off x="2047368" y="3544062"/>
             <a:ext cx="240196" cy="117347"/>
           </a:xfrm>
           <a:prstGeom prst="rect">
@@ -9422,7 +9422,7 @@
         </p:nvSpPr>
         <p:spPr>
           <a:xfrm>
-            <a:off x="2288116" y="3868420"/>
+            <a:off x="2288116" y="3531870"/>
             <a:ext cx="347150" cy="142239"/>
           </a:xfrm>
           <a:prstGeom prst="rect">
@@ -9457,7 +9457,7 @@
         </p:nvSpPr>
         <p:spPr>
           <a:xfrm>
-            <a:off x="2116666" y="4032504"/>
+            <a:off x="2116666" y="3671824"/>
             <a:ext cx="864506" cy="128015"/>
           </a:xfrm>
           <a:prstGeom prst="rect">
@@ -9492,7 +9492,7 @@
         </p:nvSpPr>
         <p:spPr>
           <a:xfrm>
-            <a:off x="2116666" y="4141724"/>
+            <a:off x="2116666" y="3775964"/>
             <a:ext cx="621964" cy="128015"/>
           </a:xfrm>
           <a:prstGeom prst="rect">
@@ -9527,7 +9527,7 @@
         </p:nvSpPr>
         <p:spPr>
           <a:xfrm>
-            <a:off x="2116666" y="4250944"/>
+            <a:off x="2116666" y="3880104"/>
             <a:ext cx="1032779" cy="128015"/>
           </a:xfrm>
           <a:prstGeom prst="rect">

</xml_diff>

<commit_message>
Writing pass: story links between sections, one term per concept, shorter sentences, no defensive asides
Abstract and body rewritten without changing results: section openers tie back to
the chain of decisions, 'single query' / 'codebook' / 'verify-and-repair' used
throughout, long colon-and-semicolon sentences split, 'not A; it B' rebuttals
and defensive caveats removed. Hard-level factor corrected to the measured
4.7 / 4.9 / 14 (was 'five or more'). Figure 1 panel 2 renamed 'A single-query
baseline'. Evidence heatmap defined before RQ2 so it sits beside its text.

Co-Authored-By: Claude Opus 5.5 <noreply@anthropic.com>
</commit_message>
<xml_diff>
--- a/docs/draft/Figures/worked_example_editable.pptx
+++ b/docs/draft/Figures/worked_example_editable.pptx
@@ -7736,7 +7736,7 @@
         <p:spPr>
           <a:xfrm>
             <a:off x="127000" y="2424430"/>
-            <a:ext cx="1342470" cy="191770"/>
+            <a:ext cx="1481218" cy="191770"/>
           </a:xfrm>
           <a:prstGeom prst="rect">
             <a:avLst/>
@@ -7780,7 +7780,7 @@
         <p:spPr>
           <a:xfrm>
             <a:off x="184150" y="2470444"/>
-            <a:ext cx="1449425" cy="170688"/>
+            <a:ext cx="1598092" cy="170688"/>
           </a:xfrm>
           <a:prstGeom prst="rect">
             <a:avLst/>
@@ -7801,7 +7801,7 @@
                 </a:solidFill>
                 <a:latin typeface="Bangers"/>
               </a:rPr>
-              <a:t>2  A ONE-QUERY BASELINE</a:t>
+              <a:t>2  A SINGLE-QUERY BASELINE</a:t>
             </a:r>
           </a:p>
         </p:txBody>

</xml_diff>